<commit_message>
PAUSED (task156): loop 3 at stage 4, every free gate green and the leak reader clean, the judge thread running
target.zip f17b387d: checks 110, verify agreeing (32 FTE: 5 2 6 4 4 2 4 3 2), two byte-identical
builds, figures_check 112/0, precut 52/0, voice-check PASS, leak.py REVIEW with no LEAK (no file
describes the data), heart WARN, surface with no hard tell (task157, task452 and task265
differentiated on the card). The isolated leak reader found no decisive-step sentence, no ranking
file and no helper-only file, and classed the decision analytical. Resume: the judge thread's
verdict, the pass-3 report, then RESHIPPED.

Co-Authored-By: Claude Opus 5.5 <noreply@anthropic.com>
Claude-Session: https://claude.ai/code/session_0142Jt4Mt622iBfGoK24ivCU
</commit_message>
<xml_diff>
--- a/task156/golden/council_pool_request_2027.pptx
+++ b/task156/golden/council_pool_request_2027.pptx
@@ -3120,7 +3120,7 @@
               </a:defRPr>
             </a:pPr>
             <a:r>
-              <a:t>Request 35 paid moderator FTE for 2027</a:t>
+              <a:t>Request 32 paid moderator FTE for 2027</a:t>
             </a:r>
           </a:p>
           <a:p>
@@ -3136,7 +3136,7 @@
               </a:defRPr>
             </a:pPr>
             <a:r>
-              <a:t>9 FTE above finance's 2027 envelope of 26 FTE (27 FTE funded for 2026)</a:t>
+              <a:t>6 FTE above finance's 2027 envelope of 26 FTE (27 FTE funded for 2026)</a:t>
             </a:r>
           </a:p>
         </p:txBody>
@@ -3352,7 +3352,7 @@
                         </a:defRPr>
                       </a:pPr>
                       <a:r>
-                        <a:t>7</a:t>
+                        <a:t>6</a:t>
                       </a:r>
                     </a:p>
                   </a:txBody>
@@ -3402,7 +3402,7 @@
                         </a:defRPr>
                       </a:pPr>
                       <a:r>
-                        <a:t>5</a:t>
+                        <a:t>4</a:t>
                       </a:r>
                     </a:p>
                   </a:txBody>
@@ -3452,7 +3452,7 @@
                         </a:defRPr>
                       </a:pPr>
                       <a:r>
-                        <a:t>5</a:t>
+                        <a:t>4</a:t>
                       </a:r>
                     </a:p>
                   </a:txBody>
@@ -3702,7 +3702,7 @@
                         </a:defRPr>
                       </a:pPr>
                       <a:r>
-                        <a:t>35</a:t>
+                        <a:t>32</a:t>
                       </a:r>
                     </a:p>
                   </a:txBody>
@@ -3780,7 +3780,7 @@
               </a:defRPr>
             </a:pPr>
             <a:r>
-              <a:t>Each site's pool loses about 2 per cent of its reviewers a month, and almost no member has been granted review access since late 2024 (2,871 new reviewers in 2024, 70 since).</a:t>
+              <a:t>Review access has been by invitation only since 1 September 2026, so the pools only shrink. The newest reviewers leave fastest (about 9 per cent a month in their first year, under one per cent from their fourth): the 10,607 reviewers active in September 2026 average about 8,800 a month in 2027.</a:t>
             </a:r>
           </a:p>
           <a:p>
@@ -3812,7 +3812,7 @@
               </a:defRPr>
             </a:pPr>
             <a:r>
-              <a:t>Priced at the 2027 standards (close votes at 2.0 minutes, down from 5.0), the nine sites need 35 FTE.</a:t>
+              <a:t>Priced at the 2027 standards (close votes at 2.0 minutes, down from 5.0), the nine sites need 32 FTE.</a:t>
             </a:r>
           </a:p>
         </p:txBody>
@@ -3974,7 +3974,7 @@
               </a:defRPr>
             </a:pPr>
             <a:r>
-              <a:t>2027 needs 35 FTE of paid review hours against an envelope of 26</a:t>
+              <a:t>2027 needs 32 FTE of paid review hours against an envelope of 26</a:t>
             </a:r>
           </a:p>
           <a:p>

</xml_diff>